<commit_message>
Change color of coordinate system "B"
</commit_message>
<xml_diff>
--- a/thesis/plots/rotation_90_around_x_axis.pptx
+++ b/thesis/plots/rotation_90_around_x_axis.pptx
@@ -259,7 +259,7 @@
           <a:p>
             <a:fld id="{F168D89B-229C-5345-8340-17EE0F917903}" type="datetimeFigureOut">
               <a:rPr lang="de-DE" smtClean="0"/>
-              <a:t>17.04.24</a:t>
+              <a:t>19.04.24</a:t>
             </a:fld>
             <a:endParaRPr lang="de-DE"/>
           </a:p>
@@ -457,7 +457,7 @@
           <a:p>
             <a:fld id="{F168D89B-229C-5345-8340-17EE0F917903}" type="datetimeFigureOut">
               <a:rPr lang="de-DE" smtClean="0"/>
-              <a:t>17.04.24</a:t>
+              <a:t>19.04.24</a:t>
             </a:fld>
             <a:endParaRPr lang="de-DE"/>
           </a:p>
@@ -665,7 +665,7 @@
           <a:p>
             <a:fld id="{F168D89B-229C-5345-8340-17EE0F917903}" type="datetimeFigureOut">
               <a:rPr lang="de-DE" smtClean="0"/>
-              <a:t>17.04.24</a:t>
+              <a:t>19.04.24</a:t>
             </a:fld>
             <a:endParaRPr lang="de-DE"/>
           </a:p>
@@ -863,7 +863,7 @@
           <a:p>
             <a:fld id="{F168D89B-229C-5345-8340-17EE0F917903}" type="datetimeFigureOut">
               <a:rPr lang="de-DE" smtClean="0"/>
-              <a:t>17.04.24</a:t>
+              <a:t>19.04.24</a:t>
             </a:fld>
             <a:endParaRPr lang="de-DE"/>
           </a:p>
@@ -1138,7 +1138,7 @@
           <a:p>
             <a:fld id="{F168D89B-229C-5345-8340-17EE0F917903}" type="datetimeFigureOut">
               <a:rPr lang="de-DE" smtClean="0"/>
-              <a:t>17.04.24</a:t>
+              <a:t>19.04.24</a:t>
             </a:fld>
             <a:endParaRPr lang="de-DE"/>
           </a:p>
@@ -1403,7 +1403,7 @@
           <a:p>
             <a:fld id="{F168D89B-229C-5345-8340-17EE0F917903}" type="datetimeFigureOut">
               <a:rPr lang="de-DE" smtClean="0"/>
-              <a:t>17.04.24</a:t>
+              <a:t>19.04.24</a:t>
             </a:fld>
             <a:endParaRPr lang="de-DE"/>
           </a:p>
@@ -1815,7 +1815,7 @@
           <a:p>
             <a:fld id="{F168D89B-229C-5345-8340-17EE0F917903}" type="datetimeFigureOut">
               <a:rPr lang="de-DE" smtClean="0"/>
-              <a:t>17.04.24</a:t>
+              <a:t>19.04.24</a:t>
             </a:fld>
             <a:endParaRPr lang="de-DE"/>
           </a:p>
@@ -1956,7 +1956,7 @@
           <a:p>
             <a:fld id="{F168D89B-229C-5345-8340-17EE0F917903}" type="datetimeFigureOut">
               <a:rPr lang="de-DE" smtClean="0"/>
-              <a:t>17.04.24</a:t>
+              <a:t>19.04.24</a:t>
             </a:fld>
             <a:endParaRPr lang="de-DE"/>
           </a:p>
@@ -2069,7 +2069,7 @@
           <a:p>
             <a:fld id="{F168D89B-229C-5345-8340-17EE0F917903}" type="datetimeFigureOut">
               <a:rPr lang="de-DE" smtClean="0"/>
-              <a:t>17.04.24</a:t>
+              <a:t>19.04.24</a:t>
             </a:fld>
             <a:endParaRPr lang="de-DE"/>
           </a:p>
@@ -2380,7 +2380,7 @@
           <a:p>
             <a:fld id="{F168D89B-229C-5345-8340-17EE0F917903}" type="datetimeFigureOut">
               <a:rPr lang="de-DE" smtClean="0"/>
-              <a:t>17.04.24</a:t>
+              <a:t>19.04.24</a:t>
             </a:fld>
             <a:endParaRPr lang="de-DE"/>
           </a:p>
@@ -2668,7 +2668,7 @@
           <a:p>
             <a:fld id="{F168D89B-229C-5345-8340-17EE0F917903}" type="datetimeFigureOut">
               <a:rPr lang="de-DE" smtClean="0"/>
-              <a:t>17.04.24</a:t>
+              <a:t>19.04.24</a:t>
             </a:fld>
             <a:endParaRPr lang="de-DE"/>
           </a:p>
@@ -2909,7 +2909,7 @@
           <a:p>
             <a:fld id="{F168D89B-229C-5345-8340-17EE0F917903}" type="datetimeFigureOut">
               <a:rPr lang="de-DE" smtClean="0"/>
-              <a:t>17.04.24</a:t>
+              <a:t>19.04.24</a:t>
             </a:fld>
             <a:endParaRPr lang="de-DE"/>
           </a:p>
@@ -3406,8 +3406,8 @@
           </a:fontRef>
         </p:style>
       </p:cxnSp>
-      <mc:AlternateContent xmlns:mc="http://schemas.openxmlformats.org/markup-compatibility/2006">
-        <mc:Choice xmlns:a14="http://schemas.microsoft.com/office/drawing/2010/main" Requires="a14">
+      <mc:AlternateContent xmlns:mc="http://schemas.openxmlformats.org/markup-compatibility/2006" xmlns:a14="http://schemas.microsoft.com/office/drawing/2010/main">
+        <mc:Choice Requires="a14">
           <p:sp>
             <p:nvSpPr>
               <p:cNvPr id="9" name="Textfeld 8">
@@ -3436,6 +3436,7 @@
               </a:bodyPr>
               <a:lstStyle/>
               <a:p>
+                <a:pPr/>
                 <a14:m>
                   <m:oMathPara xmlns:m="http://schemas.openxmlformats.org/officeDocument/2006/math">
                     <m:oMathParaPr>
@@ -3456,7 +3457,7 @@
             </p:txBody>
           </p:sp>
         </mc:Choice>
-        <mc:Fallback>
+        <mc:Fallback xmlns="">
           <p:sp>
             <p:nvSpPr>
               <p:cNvPr id="9" name="Textfeld 8">
@@ -3501,8 +3502,8 @@
           </p:sp>
         </mc:Fallback>
       </mc:AlternateContent>
-      <mc:AlternateContent xmlns:mc="http://schemas.openxmlformats.org/markup-compatibility/2006">
-        <mc:Choice xmlns:a14="http://schemas.microsoft.com/office/drawing/2010/main" Requires="a14">
+      <mc:AlternateContent xmlns:mc="http://schemas.openxmlformats.org/markup-compatibility/2006" xmlns:a14="http://schemas.microsoft.com/office/drawing/2010/main">
+        <mc:Choice Requires="a14">
           <p:sp>
             <p:nvSpPr>
               <p:cNvPr id="10" name="Textfeld 9">
@@ -3531,6 +3532,7 @@
               </a:bodyPr>
               <a:lstStyle/>
               <a:p>
+                <a:pPr/>
                 <a14:m>
                   <m:oMathPara xmlns:m="http://schemas.openxmlformats.org/officeDocument/2006/math">
                     <m:oMathParaPr>
@@ -3551,7 +3553,7 @@
             </p:txBody>
           </p:sp>
         </mc:Choice>
-        <mc:Fallback>
+        <mc:Fallback xmlns="">
           <p:sp>
             <p:nvSpPr>
               <p:cNvPr id="10" name="Textfeld 9">
@@ -3596,8 +3598,8 @@
           </p:sp>
         </mc:Fallback>
       </mc:AlternateContent>
-      <mc:AlternateContent xmlns:mc="http://schemas.openxmlformats.org/markup-compatibility/2006">
-        <mc:Choice xmlns:a14="http://schemas.microsoft.com/office/drawing/2010/main" Requires="a14">
+      <mc:AlternateContent xmlns:mc="http://schemas.openxmlformats.org/markup-compatibility/2006" xmlns:a14="http://schemas.microsoft.com/office/drawing/2010/main">
+        <mc:Choice Requires="a14">
           <p:sp>
             <p:nvSpPr>
               <p:cNvPr id="11" name="Textfeld 10">
@@ -3626,6 +3628,7 @@
               </a:bodyPr>
               <a:lstStyle/>
               <a:p>
+                <a:pPr/>
                 <a14:m>
                   <m:oMathPara xmlns:m="http://schemas.openxmlformats.org/officeDocument/2006/math">
                     <m:oMathParaPr>
@@ -3646,7 +3649,7 @@
             </p:txBody>
           </p:sp>
         </mc:Choice>
-        <mc:Fallback>
+        <mc:Fallback xmlns="">
           <p:sp>
             <p:nvSpPr>
               <p:cNvPr id="11" name="Textfeld 10">
@@ -3691,8 +3694,8 @@
           </p:sp>
         </mc:Fallback>
       </mc:AlternateContent>
-      <mc:AlternateContent xmlns:mc="http://schemas.openxmlformats.org/markup-compatibility/2006">
-        <mc:Choice xmlns:a14="http://schemas.microsoft.com/office/drawing/2010/main" Requires="a14">
+      <mc:AlternateContent xmlns:mc="http://schemas.openxmlformats.org/markup-compatibility/2006" xmlns:a14="http://schemas.microsoft.com/office/drawing/2010/main">
+        <mc:Choice Requires="a14">
           <p:sp>
             <p:nvSpPr>
               <p:cNvPr id="12" name="Textfeld 11">
@@ -3721,6 +3724,7 @@
               </a:bodyPr>
               <a:lstStyle/>
               <a:p>
+                <a:pPr/>
                 <a14:m>
                   <m:oMathPara xmlns:m="http://schemas.openxmlformats.org/officeDocument/2006/math">
                     <m:oMathParaPr>
@@ -3741,7 +3745,7 @@
             </p:txBody>
           </p:sp>
         </mc:Choice>
-        <mc:Fallback>
+        <mc:Fallback xmlns="">
           <p:sp>
             <p:nvSpPr>
               <p:cNvPr id="12" name="Textfeld 11">
@@ -3810,7 +3814,7 @@
           </a:prstGeom>
           <a:ln w="44450">
             <a:solidFill>
-              <a:srgbClr val="0070C0"/>
+              <a:srgbClr val="92D050"/>
             </a:solidFill>
             <a:prstDash val="dash"/>
             <a:tailEnd type="triangle"/>
@@ -3855,7 +3859,7 @@
           </a:prstGeom>
           <a:ln w="44450">
             <a:solidFill>
-              <a:srgbClr val="0070C0"/>
+              <a:srgbClr val="92D050"/>
             </a:solidFill>
             <a:prstDash val="dash"/>
             <a:tailEnd type="triangle"/>
@@ -3900,7 +3904,7 @@
           </a:prstGeom>
           <a:ln w="44450">
             <a:solidFill>
-              <a:srgbClr val="0070C0"/>
+              <a:srgbClr val="92D050"/>
             </a:solidFill>
             <a:prstDash val="dash"/>
             <a:tailEnd type="triangle"/>
@@ -3992,6 +3996,7 @@
               </a:bodyPr>
               <a:lstStyle/>
               <a:p>
+                <a:pPr/>
                 <a14:m>
                   <m:oMathPara xmlns:m="http://schemas.openxmlformats.org/officeDocument/2006/math">
                     <m:oMathParaPr>
@@ -4001,7 +4006,7 @@
                       <m:r>
                         <a:rPr lang="de-DE" i="1" dirty="0" smtClean="0">
                           <a:solidFill>
-                            <a:srgbClr val="0070C0"/>
+                            <a:srgbClr val="92D050"/>
                           </a:solidFill>
                           <a:latin typeface="Cambria Math" panose="02040503050406030204" pitchFamily="18" charset="0"/>
                         </a:rPr>
@@ -4012,7 +4017,7 @@
                 </a14:m>
                 <a:endParaRPr lang="de-DE" dirty="0">
                   <a:solidFill>
-                    <a:srgbClr val="0070C0"/>
+                    <a:srgbClr val="92D050"/>
                   </a:solidFill>
                 </a:endParaRPr>
               </a:p>
@@ -4094,6 +4099,7 @@
               </a:bodyPr>
               <a:lstStyle/>
               <a:p>
+                <a:pPr/>
                 <a14:m>
                   <m:oMathPara xmlns:m="http://schemas.openxmlformats.org/officeDocument/2006/math">
                     <m:oMathParaPr>
@@ -4103,7 +4109,7 @@
                       <m:r>
                         <a:rPr lang="de-DE" i="1" dirty="0" smtClean="0">
                           <a:solidFill>
-                            <a:srgbClr val="0070C0"/>
+                            <a:srgbClr val="92D050"/>
                           </a:solidFill>
                           <a:latin typeface="Cambria Math" panose="02040503050406030204" pitchFamily="18" charset="0"/>
                         </a:rPr>
@@ -4114,7 +4120,7 @@
                 </a14:m>
                 <a:endParaRPr lang="de-DE" dirty="0">
                   <a:solidFill>
-                    <a:srgbClr val="0070C0"/>
+                    <a:srgbClr val="92D050"/>
                   </a:solidFill>
                 </a:endParaRPr>
               </a:p>
@@ -4196,6 +4202,7 @@
               </a:bodyPr>
               <a:lstStyle/>
               <a:p>
+                <a:pPr/>
                 <a14:m>
                   <m:oMathPara xmlns:m="http://schemas.openxmlformats.org/officeDocument/2006/math">
                     <m:oMathParaPr>
@@ -4205,7 +4212,7 @@
                       <m:r>
                         <a:rPr lang="de-DE" i="1" dirty="0" smtClean="0">
                           <a:solidFill>
-                            <a:srgbClr val="0070C0"/>
+                            <a:srgbClr val="92D050"/>
                           </a:solidFill>
                           <a:latin typeface="Cambria Math" panose="02040503050406030204" pitchFamily="18" charset="0"/>
                         </a:rPr>
@@ -4216,7 +4223,7 @@
                 </a14:m>
                 <a:endParaRPr lang="de-DE" dirty="0">
                   <a:solidFill>
-                    <a:srgbClr val="0070C0"/>
+                    <a:srgbClr val="92D050"/>
                   </a:solidFill>
                 </a:endParaRPr>
               </a:p>
@@ -4298,6 +4305,7 @@
               </a:bodyPr>
               <a:lstStyle/>
               <a:p>
+                <a:pPr/>
                 <a14:m>
                   <m:oMathPara xmlns:m="http://schemas.openxmlformats.org/officeDocument/2006/math">
                     <m:oMathParaPr>
@@ -4307,7 +4315,7 @@
                       <m:r>
                         <a:rPr lang="de-DE" i="1" dirty="0" smtClean="0">
                           <a:solidFill>
-                            <a:srgbClr val="0070C0"/>
+                            <a:srgbClr val="92D050"/>
                           </a:solidFill>
                           <a:latin typeface="Cambria Math" panose="02040503050406030204" pitchFamily="18" charset="0"/>
                         </a:rPr>
@@ -4318,7 +4326,7 @@
                 </a14:m>
                 <a:endParaRPr lang="de-DE" dirty="0">
                   <a:solidFill>
-                    <a:srgbClr val="0070C0"/>
+                    <a:srgbClr val="92D050"/>
                   </a:solidFill>
                 </a:endParaRPr>
               </a:p>

</xml_diff>